<commit_message>
flow updated with ai algo for difficulty flow with update docs
</commit_message>
<xml_diff>
--- a/Adaptive_Quiz_Presentation.pptx
+++ b/Adaptive_Quiz_Presentation.pptx
@@ -2928,6 +2928,10 @@
           </a:effectRef>
           <a:fontRef idx="minor"/>
         </p:style>
+        <p:txBody>
+          <a:bodyPr/>
+          <a:p/>
+        </p:txBody>
       </p:sp>
       <p:sp>
         <p:nvSpPr>
@@ -3071,6 +3075,10 @@
           </a:effectRef>
           <a:fontRef idx="minor"/>
         </p:style>
+        <p:txBody>
+          <a:bodyPr/>
+          <a:p/>
+        </p:txBody>
       </p:sp>
       <p:sp>
         <p:nvSpPr>
@@ -3327,6 +3335,30 @@
           </a:p>
         </p:txBody>
       </p:sp>
+      <p:pic>
+        <p:nvPicPr>
+          <p:cNvPr id="50" name="CU_LOGO" descr="cu logo.png"/>
+          <p:cNvPicPr>
+            <a:picLocks noChangeAspect="1"/>
+          </p:cNvPicPr>
+          <p:nvPr/>
+        </p:nvPicPr>
+        <p:blipFill>
+          <a:blip r:embed="rId2"/>
+          <a:stretch>
+            <a:fillRect/>
+          </a:stretch>
+        </p:blipFill>
+        <p:spPr>
+          <a:xfrm>
+            <a:off x="10610088" y="109728"/>
+            <a:ext cx="1417320" cy="384048"/>
+          </a:xfrm>
+          <a:prstGeom prst="rect">
+            <a:avLst/>
+          </a:prstGeom>
+        </p:spPr>
+      </p:pic>
     </p:spTree>
   </p:cSld>
   <mc:AlternateContent>
@@ -3397,6 +3429,10 @@
           </a:effectRef>
           <a:fontRef idx="minor"/>
         </p:style>
+        <p:txBody>
+          <a:bodyPr/>
+          <a:p/>
+        </p:txBody>
       </p:sp>
       <p:sp>
         <p:nvSpPr>
@@ -3428,7 +3464,7 @@
             <a:spAutoFit/>
           </a:bodyPr>
           <a:p>
-            <a:pPr>
+            <a:pPr algn="ctr">
               <a:lnSpc>
                 <a:spcPct val="100000"/>
               </a:lnSpc>
@@ -3625,6 +3661,30 @@
           </a:p>
         </p:txBody>
       </p:sp>
+      <p:pic>
+        <p:nvPicPr>
+          <p:cNvPr id="116" name="CU_LOGO" descr="cu logo.png"/>
+          <p:cNvPicPr>
+            <a:picLocks noChangeAspect="1"/>
+          </p:cNvPicPr>
+          <p:nvPr/>
+        </p:nvPicPr>
+        <p:blipFill>
+          <a:blip r:embed="rId3"/>
+          <a:stretch>
+            <a:fillRect/>
+          </a:stretch>
+        </p:blipFill>
+        <p:spPr>
+          <a:xfrm>
+            <a:off x="10610088" y="109728"/>
+            <a:ext cx="1417320" cy="384048"/>
+          </a:xfrm>
+          <a:prstGeom prst="rect">
+            <a:avLst/>
+          </a:prstGeom>
+        </p:spPr>
+      </p:pic>
     </p:spTree>
   </p:cSld>
   <mc:AlternateContent>
@@ -3695,6 +3755,10 @@
           </a:effectRef>
           <a:fontRef idx="minor"/>
         </p:style>
+        <p:txBody>
+          <a:bodyPr/>
+          <a:p/>
+        </p:txBody>
       </p:sp>
       <p:sp>
         <p:nvSpPr>
@@ -3726,7 +3790,7 @@
             <a:spAutoFit/>
           </a:bodyPr>
           <a:p>
-            <a:pPr>
+            <a:pPr algn="ctr">
               <a:lnSpc>
                 <a:spcPct val="100000"/>
               </a:lnSpc>
@@ -3923,6 +3987,30 @@
           </a:p>
         </p:txBody>
       </p:sp>
+      <p:pic>
+        <p:nvPicPr>
+          <p:cNvPr id="122" name="CU_LOGO" descr="cu logo.png"/>
+          <p:cNvPicPr>
+            <a:picLocks noChangeAspect="1"/>
+          </p:cNvPicPr>
+          <p:nvPr/>
+        </p:nvPicPr>
+        <p:blipFill>
+          <a:blip r:embed="rId3"/>
+          <a:stretch>
+            <a:fillRect/>
+          </a:stretch>
+        </p:blipFill>
+        <p:spPr>
+          <a:xfrm>
+            <a:off x="10610088" y="109728"/>
+            <a:ext cx="1417320" cy="384048"/>
+          </a:xfrm>
+          <a:prstGeom prst="rect">
+            <a:avLst/>
+          </a:prstGeom>
+        </p:spPr>
+      </p:pic>
     </p:spTree>
   </p:cSld>
   <mc:AlternateContent>
@@ -3993,6 +4081,10 @@
           </a:effectRef>
           <a:fontRef idx="minor"/>
         </p:style>
+        <p:txBody>
+          <a:bodyPr/>
+          <a:p/>
+        </p:txBody>
       </p:sp>
       <p:sp>
         <p:nvSpPr>
@@ -4024,7 +4116,7 @@
             <a:spAutoFit/>
           </a:bodyPr>
           <a:p>
-            <a:pPr>
+            <a:pPr algn="ctr">
               <a:lnSpc>
                 <a:spcPct val="100000"/>
               </a:lnSpc>
@@ -4221,6 +4313,30 @@
           </a:p>
         </p:txBody>
       </p:sp>
+      <p:pic>
+        <p:nvPicPr>
+          <p:cNvPr id="128" name="CU_LOGO" descr="cu logo.png"/>
+          <p:cNvPicPr>
+            <a:picLocks noChangeAspect="1"/>
+          </p:cNvPicPr>
+          <p:nvPr/>
+        </p:nvPicPr>
+        <p:blipFill>
+          <a:blip r:embed="rId3"/>
+          <a:stretch>
+            <a:fillRect/>
+          </a:stretch>
+        </p:blipFill>
+        <p:spPr>
+          <a:xfrm>
+            <a:off x="10610088" y="109728"/>
+            <a:ext cx="1417320" cy="384048"/>
+          </a:xfrm>
+          <a:prstGeom prst="rect">
+            <a:avLst/>
+          </a:prstGeom>
+        </p:spPr>
+      </p:pic>
     </p:spTree>
   </p:cSld>
   <mc:AlternateContent>
@@ -4291,6 +4407,10 @@
           </a:effectRef>
           <a:fontRef idx="minor"/>
         </p:style>
+        <p:txBody>
+          <a:bodyPr/>
+          <a:p/>
+        </p:txBody>
       </p:sp>
       <p:sp>
         <p:nvSpPr>
@@ -4322,7 +4442,7 @@
             <a:spAutoFit/>
           </a:bodyPr>
           <a:p>
-            <a:pPr>
+            <a:pPr algn="ctr">
               <a:lnSpc>
                 <a:spcPct val="100000"/>
               </a:lnSpc>
@@ -4519,6 +4639,30 @@
           </a:p>
         </p:txBody>
       </p:sp>
+      <p:pic>
+        <p:nvPicPr>
+          <p:cNvPr id="134" name="CU_LOGO" descr="cu logo.png"/>
+          <p:cNvPicPr>
+            <a:picLocks noChangeAspect="1"/>
+          </p:cNvPicPr>
+          <p:nvPr/>
+        </p:nvPicPr>
+        <p:blipFill>
+          <a:blip r:embed="rId3"/>
+          <a:stretch>
+            <a:fillRect/>
+          </a:stretch>
+        </p:blipFill>
+        <p:spPr>
+          <a:xfrm>
+            <a:off x="10610088" y="109728"/>
+            <a:ext cx="1417320" cy="384048"/>
+          </a:xfrm>
+          <a:prstGeom prst="rect">
+            <a:avLst/>
+          </a:prstGeom>
+        </p:spPr>
+      </p:pic>
     </p:spTree>
   </p:cSld>
   <mc:AlternateContent>
@@ -4589,6 +4733,10 @@
           </a:effectRef>
           <a:fontRef idx="minor"/>
         </p:style>
+        <p:txBody>
+          <a:bodyPr/>
+          <a:p/>
+        </p:txBody>
       </p:sp>
       <p:sp>
         <p:nvSpPr>
@@ -4620,7 +4768,7 @@
             <a:spAutoFit/>
           </a:bodyPr>
           <a:p>
-            <a:pPr>
+            <a:pPr algn="ctr">
               <a:lnSpc>
                 <a:spcPct val="100000"/>
               </a:lnSpc>
@@ -4681,6 +4829,10 @@
           </a:effectRef>
           <a:fontRef idx="minor"/>
         </p:style>
+        <p:txBody>
+          <a:bodyPr/>
+          <a:p/>
+        </p:txBody>
       </p:sp>
       <p:sp>
         <p:nvSpPr>
@@ -4824,6 +4976,10 @@
           </a:effectRef>
           <a:fontRef idx="minor"/>
         </p:style>
+        <p:txBody>
+          <a:bodyPr/>
+          <a:p/>
+        </p:txBody>
       </p:sp>
       <p:sp>
         <p:nvSpPr>
@@ -4967,6 +5123,10 @@
           </a:effectRef>
           <a:fontRef idx="minor"/>
         </p:style>
+        <p:txBody>
+          <a:bodyPr/>
+          <a:p/>
+        </p:txBody>
       </p:sp>
       <p:sp>
         <p:nvSpPr>
@@ -5110,6 +5270,10 @@
           </a:effectRef>
           <a:fontRef idx="minor"/>
         </p:style>
+        <p:txBody>
+          <a:bodyPr/>
+          <a:p/>
+        </p:txBody>
       </p:sp>
       <p:sp>
         <p:nvSpPr>
@@ -5253,6 +5417,10 @@
           </a:effectRef>
           <a:fontRef idx="minor"/>
         </p:style>
+        <p:txBody>
+          <a:bodyPr/>
+          <a:p/>
+        </p:txBody>
       </p:sp>
       <p:sp>
         <p:nvSpPr>
@@ -5396,6 +5564,10 @@
           </a:effectRef>
           <a:fontRef idx="minor"/>
         </p:style>
+        <p:txBody>
+          <a:bodyPr/>
+          <a:p/>
+        </p:txBody>
       </p:sp>
       <p:sp>
         <p:nvSpPr>
@@ -5539,6 +5711,10 @@
           </a:effectRef>
           <a:fontRef idx="minor"/>
         </p:style>
+        <p:txBody>
+          <a:bodyPr/>
+          <a:p/>
+        </p:txBody>
       </p:sp>
       <p:sp>
         <p:nvSpPr>
@@ -5682,6 +5858,10 @@
           </a:effectRef>
           <a:fontRef idx="minor"/>
         </p:style>
+        <p:txBody>
+          <a:bodyPr/>
+          <a:p/>
+        </p:txBody>
       </p:sp>
       <p:sp>
         <p:nvSpPr>
@@ -5887,6 +6067,30 @@
           </a:p>
         </p:txBody>
       </p:sp>
+      <p:pic>
+        <p:nvPicPr>
+          <p:cNvPr id="162" name="CU_LOGO" descr="cu logo.png"/>
+          <p:cNvPicPr>
+            <a:picLocks noChangeAspect="1"/>
+          </p:cNvPicPr>
+          <p:nvPr/>
+        </p:nvPicPr>
+        <p:blipFill>
+          <a:blip r:embed="rId2"/>
+          <a:stretch>
+            <a:fillRect/>
+          </a:stretch>
+        </p:blipFill>
+        <p:spPr>
+          <a:xfrm>
+            <a:off x="10610088" y="109728"/>
+            <a:ext cx="1417320" cy="384048"/>
+          </a:xfrm>
+          <a:prstGeom prst="rect">
+            <a:avLst/>
+          </a:prstGeom>
+        </p:spPr>
+      </p:pic>
     </p:spTree>
   </p:cSld>
   <mc:AlternateContent>
@@ -5957,6 +6161,17 @@
           </a:effectRef>
           <a:fontRef idx="minor"/>
         </p:style>
+        <p:txBody>
+          <a:bodyPr/>
+          <a:p/>
+          <a:p>
+            <a:pPr lvl="1"/>
+            <a:r>
+              <a:rPr sz="1600"/>
+              <a:t>Endpoint: POST /quizzes/questions/suggest-difficulty (teacher-only, Gemini classifies text -&gt; EASY/MEDIUM/HARD)</a:t>
+            </a:r>
+          </a:p>
+        </p:txBody>
       </p:sp>
       <p:sp>
         <p:nvSpPr>
@@ -5988,7 +6203,7 @@
             <a:spAutoFit/>
           </a:bodyPr>
           <a:p>
-            <a:pPr>
+            <a:pPr algn="ctr">
               <a:lnSpc>
                 <a:spcPct val="100000"/>
               </a:lnSpc>
@@ -6049,6 +6264,10 @@
           </a:effectRef>
           <a:fontRef idx="minor"/>
         </p:style>
+        <p:txBody>
+          <a:bodyPr/>
+          <a:p/>
+        </p:txBody>
       </p:sp>
       <p:sp>
         <p:nvSpPr>
@@ -6309,6 +6528,43 @@
               <a:latin typeface="Arial"/>
             </a:endParaRPr>
           </a:p>
+          <a:p>
+            <a:pPr>
+              <a:lnSpc>
+                <a:spcPct val="100000"/>
+              </a:lnSpc>
+              <a:spcAft>
+                <a:spcPts val="799"/>
+              </a:spcAft>
+              <a:buNone/>
+            </a:pPr>
+            <a:endParaRPr b="0" lang="en-IN" sz="1800" spc="-1" strike="noStrike">
+              <a:latin typeface="Arial"/>
+            </a:endParaRPr>
+            <a:r>
+              <a:rPr b="0" lang="en-US" sz="1800" spc="-1" strike="noStrike">
+                <a:solidFill>
+                  <a:srgbClr val="1e293b"/>
+                </a:solidFill>
+                <a:latin typeface="Calibri"/>
+              </a:rPr>
+              <a:t>•  Next-question tier decided by Google Gemini (last 6 answers + ability score) via ai_difficulty.recommend_difficulty — EMA tier used as fallback when AI is off.</a:t>
+            </a:r>
+          </a:p>
+          <a:p>
+            <a:pPr/>
+            <a:r>
+              <a:rPr sz="1600"/>
+              <a:t>difficulty_override: AI-recommended tier overrides EMA; fallback order still applies if tier exhausted</a:t>
+            </a:r>
+          </a:p>
+          <a:p>
+            <a:pPr/>
+            <a:r>
+              <a:rPr sz="1600"/>
+              <a:t>Teacher difficulty suggestion: POST /quizzes/questions/suggest-difficulty -&gt; {difficulty, ai_used}; 'AI set' badge shown on blur</a:t>
+            </a:r>
+          </a:p>
         </p:txBody>
       </p:sp>
       <p:sp>
@@ -6413,6 +6669,30 @@
           </a:p>
         </p:txBody>
       </p:sp>
+      <p:pic>
+        <p:nvPicPr>
+          <p:cNvPr id="170" name="CU_LOGO" descr="cu logo.png"/>
+          <p:cNvPicPr>
+            <a:picLocks noChangeAspect="1"/>
+          </p:cNvPicPr>
+          <p:nvPr/>
+        </p:nvPicPr>
+        <p:blipFill>
+          <a:blip r:embed="rId2"/>
+          <a:stretch>
+            <a:fillRect/>
+          </a:stretch>
+        </p:blipFill>
+        <p:spPr>
+          <a:xfrm>
+            <a:off x="10610088" y="109728"/>
+            <a:ext cx="1417320" cy="384048"/>
+          </a:xfrm>
+          <a:prstGeom prst="rect">
+            <a:avLst/>
+          </a:prstGeom>
+        </p:spPr>
+      </p:pic>
     </p:spTree>
   </p:cSld>
   <mc:AlternateContent>
@@ -6483,6 +6763,10 @@
           </a:effectRef>
           <a:fontRef idx="minor"/>
         </p:style>
+        <p:txBody>
+          <a:bodyPr/>
+          <a:p/>
+        </p:txBody>
       </p:sp>
       <p:sp>
         <p:nvSpPr>
@@ -6514,7 +6798,7 @@
             <a:spAutoFit/>
           </a:bodyPr>
           <a:p>
-            <a:pPr>
+            <a:pPr algn="ctr">
               <a:lnSpc>
                 <a:spcPct val="100000"/>
               </a:lnSpc>
@@ -6774,6 +7058,36 @@
             <a:endParaRPr b="0" lang="en-IN" sz="1500" spc="-1" strike="noStrike">
               <a:latin typeface="Arial"/>
             </a:endParaRPr>
+          </a:p>
+          <a:p>
+            <a:pPr>
+              <a:lnSpc>
+                <a:spcPct val="100000"/>
+              </a:lnSpc>
+              <a:spcAft>
+                <a:spcPts val="799"/>
+              </a:spcAft>
+              <a:buNone/>
+            </a:pPr>
+            <a:endParaRPr b="0" lang="en-IN" sz="1500" spc="-1" strike="noStrike">
+              <a:latin typeface="Arial"/>
+            </a:endParaRPr>
+            <a:r>
+              <a:rPr b="0" lang="en-US" sz="1500" spc="-1" strike="noStrike">
+                <a:solidFill>
+                  <a:srgbClr val="1e293b"/>
+                </a:solidFill>
+                <a:latin typeface="Calibri"/>
+              </a:rPr>
+              <a:t>•  Teacher difficulty suggestion: on question text blur, Gemini classifies EASY/MEDIUM/HARD → difficulty dropdown auto-filled, 'AI set' badge shown; teacher can override.</a:t>
+            </a:r>
+          </a:p>
+          <a:p>
+            <a:pPr/>
+            <a:r>
+              <a:rPr sz="1600"/>
+              <a:t>Teacher: question text blur -&gt; POST /suggest-difficulty -&gt; Gemini -&gt; EASY/MEDIUM/HARD; ai_used flag drives 'AI set' badge</a:t>
+            </a:r>
           </a:p>
         </p:txBody>
       </p:sp>
@@ -6868,6 +7182,10 @@
           </a:effectRef>
           <a:fontRef idx="minor"/>
         </p:style>
+        <p:txBody>
+          <a:bodyPr/>
+          <a:p/>
+        </p:txBody>
       </p:sp>
       <p:sp>
         <p:nvSpPr>
@@ -7022,6 +7340,30 @@
           </a:p>
         </p:txBody>
       </p:sp>
+      <p:pic>
+        <p:nvPicPr>
+          <p:cNvPr id="179" name="CU_LOGO" descr="cu logo.png"/>
+          <p:cNvPicPr>
+            <a:picLocks noChangeAspect="1"/>
+          </p:cNvPicPr>
+          <p:nvPr/>
+        </p:nvPicPr>
+        <p:blipFill>
+          <a:blip r:embed="rId2"/>
+          <a:stretch>
+            <a:fillRect/>
+          </a:stretch>
+        </p:blipFill>
+        <p:spPr>
+          <a:xfrm>
+            <a:off x="10610088" y="109728"/>
+            <a:ext cx="1417320" cy="384048"/>
+          </a:xfrm>
+          <a:prstGeom prst="rect">
+            <a:avLst/>
+          </a:prstGeom>
+        </p:spPr>
+      </p:pic>
     </p:spTree>
   </p:cSld>
   <mc:AlternateContent>
@@ -7092,6 +7434,10 @@
           </a:effectRef>
           <a:fontRef idx="minor"/>
         </p:style>
+        <p:txBody>
+          <a:bodyPr/>
+          <a:p/>
+        </p:txBody>
       </p:sp>
       <p:sp>
         <p:nvSpPr>
@@ -7123,7 +7469,7 @@
             <a:spAutoFit/>
           </a:bodyPr>
           <a:p>
-            <a:pPr>
+            <a:pPr algn="ctr">
               <a:lnSpc>
                 <a:spcPct val="100000"/>
               </a:lnSpc>
@@ -7469,6 +7815,30 @@
           </a:p>
         </p:txBody>
       </p:sp>
+      <p:pic>
+        <p:nvPicPr>
+          <p:cNvPr id="184" name="CU_LOGO" descr="cu logo.png"/>
+          <p:cNvPicPr>
+            <a:picLocks noChangeAspect="1"/>
+          </p:cNvPicPr>
+          <p:nvPr/>
+        </p:nvPicPr>
+        <p:blipFill>
+          <a:blip r:embed="rId2"/>
+          <a:stretch>
+            <a:fillRect/>
+          </a:stretch>
+        </p:blipFill>
+        <p:spPr>
+          <a:xfrm>
+            <a:off x="10610088" y="109728"/>
+            <a:ext cx="1417320" cy="384048"/>
+          </a:xfrm>
+          <a:prstGeom prst="rect">
+            <a:avLst/>
+          </a:prstGeom>
+        </p:spPr>
+      </p:pic>
     </p:spTree>
   </p:cSld>
   <mc:AlternateContent>
@@ -7539,6 +7909,10 @@
           </a:effectRef>
           <a:fontRef idx="minor"/>
         </p:style>
+        <p:txBody>
+          <a:bodyPr/>
+          <a:p/>
+        </p:txBody>
       </p:sp>
       <p:sp>
         <p:nvSpPr>
@@ -7570,7 +7944,7 @@
             <a:spAutoFit/>
           </a:bodyPr>
           <a:p>
-            <a:pPr>
+            <a:pPr algn="ctr">
               <a:lnSpc>
                 <a:spcPct val="100000"/>
               </a:lnSpc>
@@ -7631,6 +8005,10 @@
           </a:effectRef>
           <a:fontRef idx="minor"/>
         </p:style>
+        <p:txBody>
+          <a:bodyPr/>
+          <a:p/>
+        </p:txBody>
       </p:sp>
       <p:sp>
         <p:nvSpPr>
@@ -7672,6 +8050,10 @@
           </a:effectRef>
           <a:fontRef idx="minor"/>
         </p:style>
+        <p:txBody>
+          <a:bodyPr/>
+          <a:p/>
+        </p:txBody>
       </p:sp>
       <p:sp>
         <p:nvSpPr>
@@ -7913,6 +8295,43 @@
               <a:latin typeface="Arial"/>
             </a:endParaRPr>
           </a:p>
+          <a:p>
+            <a:pPr/>
+            <a:r>
+              <a:rPr sz="1600"/>
+              <a:t>Resume detection: IN_PROGRESS check before POST; amber banner shown if resuming</a:t>
+            </a:r>
+          </a:p>
+          <a:p>
+            <a:pPr>
+              <a:lnSpc>
+                <a:spcPct val="100000"/>
+              </a:lnSpc>
+              <a:spcAft>
+                <a:spcPts val="799"/>
+              </a:spcAft>
+              <a:buNone/>
+            </a:pPr>
+            <a:endParaRPr b="0" lang="en-IN" sz="1400" spc="-1" strike="noStrike">
+              <a:latin typeface="Arial"/>
+            </a:endParaRPr>
+            <a:r>
+              <a:rPr b="0" lang="en-US" sz="1400" spc="-1" strike="noStrike">
+                <a:solidFill>
+                  <a:srgbClr val="1e293b"/>
+                </a:solidFill>
+                <a:latin typeface="Calibri"/>
+              </a:rPr>
+              <a:t>•  Countdown timer (MM:SS) shown in header; pulses red at ≤60 s.</a:t>
+            </a:r>
+          </a:p>
+          <a:p>
+            <a:pPr/>
+            <a:r>
+              <a:rPr sz="1600"/>
+              <a:t>Auto-abandon: deadline enforced at request time; HTTP 410 redirects student out; SYSTEM notification sent.</a:t>
+            </a:r>
+          </a:p>
         </p:txBody>
       </p:sp>
       <p:sp>
@@ -8155,6 +8574,43 @@
               <a:latin typeface="Arial"/>
             </a:endParaRPr>
           </a:p>
+          <a:p>
+            <a:pPr/>
+            <a:r>
+              <a:rPr sz="1600"/>
+              <a:t>Notification bell: mark-read on click; no auto-redirect (removed to prevent mid-flow disruption)</a:t>
+            </a:r>
+          </a:p>
+          <a:p>
+            <a:pPr>
+              <a:lnSpc>
+                <a:spcPct val="100000"/>
+              </a:lnSpc>
+              <a:spcAft>
+                <a:spcPts val="799"/>
+              </a:spcAft>
+              <a:buNone/>
+            </a:pPr>
+            <a:endParaRPr b="0" lang="en-IN" sz="1400" spc="-1" strike="noStrike">
+              <a:latin typeface="Arial"/>
+            </a:endParaRPr>
+            <a:r>
+              <a:rPr b="0" lang="en-US" sz="1400" spc="-1" strike="noStrike">
+                <a:solidFill>
+                  <a:srgbClr val="1e293b"/>
+                </a:solidFill>
+                <a:latin typeface="Calibri"/>
+              </a:rPr>
+              <a:t>•  Countdown timer shared across both modes; same expiry logic applies.</a:t>
+            </a:r>
+          </a:p>
+          <a:p>
+            <a:pPr/>
+            <a:r>
+              <a:rPr sz="1600"/>
+              <a:t>Auto-abandon: next-question &amp; submit-answer both check is_time_expired(); abandon_attempt() + HTTP 410 on expiry.</a:t>
+            </a:r>
+          </a:p>
         </p:txBody>
       </p:sp>
       <p:sp>
@@ -8259,6 +8715,30 @@
           </a:p>
         </p:txBody>
       </p:sp>
+      <p:pic>
+        <p:nvPicPr>
+          <p:cNvPr id="194" name="CU_LOGO" descr="cu logo.png"/>
+          <p:cNvPicPr>
+            <a:picLocks noChangeAspect="1"/>
+          </p:cNvPicPr>
+          <p:nvPr/>
+        </p:nvPicPr>
+        <p:blipFill>
+          <a:blip r:embed="rId2"/>
+          <a:stretch>
+            <a:fillRect/>
+          </a:stretch>
+        </p:blipFill>
+        <p:spPr>
+          <a:xfrm>
+            <a:off x="10610088" y="109728"/>
+            <a:ext cx="1417320" cy="384048"/>
+          </a:xfrm>
+          <a:prstGeom prst="rect">
+            <a:avLst/>
+          </a:prstGeom>
+        </p:spPr>
+      </p:pic>
     </p:spTree>
   </p:cSld>
   <mc:AlternateContent>
@@ -8329,6 +8809,10 @@
           </a:effectRef>
           <a:fontRef idx="minor"/>
         </p:style>
+        <p:txBody>
+          <a:bodyPr/>
+          <a:p/>
+        </p:txBody>
       </p:sp>
       <p:sp>
         <p:nvSpPr>
@@ -8360,7 +8844,7 @@
             <a:spAutoFit/>
           </a:bodyPr>
           <a:p>
-            <a:pPr>
+            <a:pPr algn="ctr">
               <a:lnSpc>
                 <a:spcPct val="100000"/>
               </a:lnSpc>
@@ -8421,6 +8905,10 @@
           </a:effectRef>
           <a:fontRef idx="minor"/>
         </p:style>
+        <p:txBody>
+          <a:bodyPr/>
+          <a:p/>
+        </p:txBody>
       </p:sp>
       <p:sp>
         <p:nvSpPr>
@@ -8516,7 +9004,7 @@
                 </a:solidFill>
                 <a:latin typeface="Calibri"/>
               </a:rPr>
-              <a:t>66 pytest tests · 95% coverage</a:t>
+              <a:t>91 pytest tests · 95% coverage</a:t>
             </a:r>
             <a:endParaRPr b="0" lang="en-IN" sz="1400" spc="-1" strike="noStrike">
               <a:latin typeface="Arial"/>
@@ -8564,6 +9052,10 @@
           </a:effectRef>
           <a:fontRef idx="minor"/>
         </p:style>
+        <p:txBody>
+          <a:bodyPr/>
+          <a:p/>
+        </p:txBody>
       </p:sp>
       <p:sp>
         <p:nvSpPr>
@@ -8659,7 +9151,7 @@
                 </a:solidFill>
                 <a:latin typeface="Calibri"/>
               </a:rPr>
-              <a:t>TypeScript strict mode · no errors</a:t>
+              <a:t>TypeScript strict · 14 Vitest UI tests · no errors</a:t>
             </a:r>
             <a:endParaRPr b="0" lang="en-IN" sz="1400" spc="-1" strike="noStrike">
               <a:latin typeface="Arial"/>
@@ -8707,6 +9199,10 @@
           </a:effectRef>
           <a:fontRef idx="minor"/>
         </p:style>
+        <p:txBody>
+          <a:bodyPr/>
+          <a:p/>
+        </p:txBody>
       </p:sp>
       <p:sp>
         <p:nvSpPr>
@@ -8850,6 +9346,10 @@
           </a:effectRef>
           <a:fontRef idx="minor"/>
         </p:style>
+        <p:txBody>
+          <a:bodyPr/>
+          <a:p/>
+        </p:txBody>
       </p:sp>
       <p:sp>
         <p:nvSpPr>
@@ -8993,6 +9493,10 @@
           </a:effectRef>
           <a:fontRef idx="minor"/>
         </p:style>
+        <p:txBody>
+          <a:bodyPr/>
+          <a:p/>
+        </p:txBody>
       </p:sp>
       <p:sp>
         <p:nvSpPr>
@@ -9136,6 +9640,10 @@
           </a:effectRef>
           <a:fontRef idx="minor"/>
         </p:style>
+        <p:txBody>
+          <a:bodyPr/>
+          <a:p/>
+        </p:txBody>
       </p:sp>
       <p:sp>
         <p:nvSpPr>
@@ -9341,6 +9849,30 @@
           </a:p>
         </p:txBody>
       </p:sp>
+      <p:pic>
+        <p:nvPicPr>
+          <p:cNvPr id="216" name="CU_LOGO" descr="cu logo.png"/>
+          <p:cNvPicPr>
+            <a:picLocks noChangeAspect="1"/>
+          </p:cNvPicPr>
+          <p:nvPr/>
+        </p:nvPicPr>
+        <p:blipFill>
+          <a:blip r:embed="rId2"/>
+          <a:stretch>
+            <a:fillRect/>
+          </a:stretch>
+        </p:blipFill>
+        <p:spPr>
+          <a:xfrm>
+            <a:off x="10610088" y="109728"/>
+            <a:ext cx="1417320" cy="384048"/>
+          </a:xfrm>
+          <a:prstGeom prst="rect">
+            <a:avLst/>
+          </a:prstGeom>
+        </p:spPr>
+      </p:pic>
     </p:spTree>
   </p:cSld>
   <mc:AlternateContent>
@@ -9411,6 +9943,10 @@
           </a:effectRef>
           <a:fontRef idx="minor"/>
         </p:style>
+        <p:txBody>
+          <a:bodyPr/>
+          <a:p/>
+        </p:txBody>
       </p:sp>
       <p:sp>
         <p:nvSpPr>
@@ -9442,7 +9978,7 @@
             <a:spAutoFit/>
           </a:bodyPr>
           <a:p>
-            <a:pPr>
+            <a:pPr algn="ctr">
               <a:lnSpc>
                 <a:spcPct val="100000"/>
               </a:lnSpc>
@@ -9884,6 +10420,30 @@
           </a:p>
         </p:txBody>
       </p:sp>
+      <p:pic>
+        <p:nvPicPr>
+          <p:cNvPr id="55" name="CU_LOGO" descr="cu logo.png"/>
+          <p:cNvPicPr>
+            <a:picLocks noChangeAspect="1"/>
+          </p:cNvPicPr>
+          <p:nvPr/>
+        </p:nvPicPr>
+        <p:blipFill>
+          <a:blip r:embed="rId2"/>
+          <a:stretch>
+            <a:fillRect/>
+          </a:stretch>
+        </p:blipFill>
+        <p:spPr>
+          <a:xfrm>
+            <a:off x="10610088" y="109728"/>
+            <a:ext cx="1417320" cy="384048"/>
+          </a:xfrm>
+          <a:prstGeom prst="rect">
+            <a:avLst/>
+          </a:prstGeom>
+        </p:spPr>
+      </p:pic>
     </p:spTree>
   </p:cSld>
   <mc:AlternateContent>
@@ -9954,6 +10514,10 @@
           </a:effectRef>
           <a:fontRef idx="minor"/>
         </p:style>
+        <p:txBody>
+          <a:bodyPr/>
+          <a:p/>
+        </p:txBody>
       </p:sp>
       <p:sp>
         <p:nvSpPr>
@@ -9985,7 +10549,7 @@
             <a:spAutoFit/>
           </a:bodyPr>
           <a:p>
-            <a:pPr>
+            <a:pPr algn="ctr">
               <a:lnSpc>
                 <a:spcPct val="100000"/>
               </a:lnSpc>
@@ -10046,6 +10610,10 @@
           </a:effectRef>
           <a:fontRef idx="minor"/>
         </p:style>
+        <p:txBody>
+          <a:bodyPr/>
+          <a:p/>
+        </p:txBody>
       </p:sp>
       <p:sp>
         <p:nvSpPr>
@@ -10393,6 +10961,10 @@
           </a:effectRef>
           <a:fontRef idx="minor"/>
         </p:style>
+        <p:txBody>
+          <a:bodyPr/>
+          <a:p/>
+        </p:txBody>
       </p:sp>
       <p:sp>
         <p:nvSpPr>
@@ -10740,6 +11312,10 @@
           </a:effectRef>
           <a:fontRef idx="minor"/>
         </p:style>
+        <p:txBody>
+          <a:bodyPr/>
+          <a:p/>
+        </p:txBody>
       </p:sp>
       <p:sp>
         <p:nvSpPr>
@@ -11087,6 +11663,10 @@
           </a:effectRef>
           <a:fontRef idx="minor"/>
         </p:style>
+        <p:txBody>
+          <a:bodyPr/>
+          <a:p/>
+        </p:txBody>
       </p:sp>
       <p:sp>
         <p:nvSpPr>
@@ -11443,6 +12023,10 @@
           </a:effectRef>
           <a:fontRef idx="minor"/>
         </p:style>
+        <p:txBody>
+          <a:bodyPr/>
+          <a:p/>
+        </p:txBody>
       </p:sp>
       <p:sp>
         <p:nvSpPr>
@@ -11790,6 +12374,10 @@
           </a:effectRef>
           <a:fontRef idx="minor"/>
         </p:style>
+        <p:txBody>
+          <a:bodyPr/>
+          <a:p/>
+        </p:txBody>
       </p:sp>
       <p:sp>
         <p:nvSpPr>
@@ -12199,6 +12787,30 @@
           </a:p>
         </p:txBody>
       </p:sp>
+      <p:pic>
+        <p:nvPicPr>
+          <p:cNvPr id="262" name="CU_LOGO" descr="cu logo.png"/>
+          <p:cNvPicPr>
+            <a:picLocks noChangeAspect="1"/>
+          </p:cNvPicPr>
+          <p:nvPr/>
+        </p:nvPicPr>
+        <p:blipFill>
+          <a:blip r:embed="rId2"/>
+          <a:stretch>
+            <a:fillRect/>
+          </a:stretch>
+        </p:blipFill>
+        <p:spPr>
+          <a:xfrm>
+            <a:off x="10610088" y="109728"/>
+            <a:ext cx="1417320" cy="384048"/>
+          </a:xfrm>
+          <a:prstGeom prst="rect">
+            <a:avLst/>
+          </a:prstGeom>
+        </p:spPr>
+      </p:pic>
     </p:spTree>
   </p:cSld>
   <mc:AlternateContent>
@@ -12269,6 +12881,10 @@
           </a:effectRef>
           <a:fontRef idx="minor"/>
         </p:style>
+        <p:txBody>
+          <a:bodyPr/>
+          <a:p/>
+        </p:txBody>
       </p:sp>
       <p:sp>
         <p:nvSpPr>
@@ -12300,7 +12916,7 @@
             <a:spAutoFit/>
           </a:bodyPr>
           <a:p>
-            <a:pPr>
+            <a:pPr algn="ctr">
               <a:lnSpc>
                 <a:spcPct val="100000"/>
               </a:lnSpc>
@@ -12646,6 +13262,30 @@
           </a:p>
         </p:txBody>
       </p:sp>
+      <p:pic>
+        <p:nvPicPr>
+          <p:cNvPr id="267" name="CU_LOGO" descr="cu logo.png"/>
+          <p:cNvPicPr>
+            <a:picLocks noChangeAspect="1"/>
+          </p:cNvPicPr>
+          <p:nvPr/>
+        </p:nvPicPr>
+        <p:blipFill>
+          <a:blip r:embed="rId2"/>
+          <a:stretch>
+            <a:fillRect/>
+          </a:stretch>
+        </p:blipFill>
+        <p:spPr>
+          <a:xfrm>
+            <a:off x="10610088" y="109728"/>
+            <a:ext cx="1417320" cy="384048"/>
+          </a:xfrm>
+          <a:prstGeom prst="rect">
+            <a:avLst/>
+          </a:prstGeom>
+        </p:spPr>
+      </p:pic>
     </p:spTree>
   </p:cSld>
   <mc:AlternateContent>
@@ -12716,6 +13356,10 @@
           </a:effectRef>
           <a:fontRef idx="minor"/>
         </p:style>
+        <p:txBody>
+          <a:bodyPr/>
+          <a:p/>
+        </p:txBody>
       </p:sp>
       <p:sp>
         <p:nvSpPr>
@@ -12921,6 +13565,30 @@
           </a:p>
         </p:txBody>
       </p:sp>
+      <p:pic>
+        <p:nvPicPr>
+          <p:cNvPr id="272" name="CU_LOGO" descr="cu logo.png"/>
+          <p:cNvPicPr>
+            <a:picLocks noChangeAspect="1"/>
+          </p:cNvPicPr>
+          <p:nvPr/>
+        </p:nvPicPr>
+        <p:blipFill>
+          <a:blip r:embed="rId2"/>
+          <a:stretch>
+            <a:fillRect/>
+          </a:stretch>
+        </p:blipFill>
+        <p:spPr>
+          <a:xfrm>
+            <a:off x="10610088" y="109728"/>
+            <a:ext cx="1417320" cy="384048"/>
+          </a:xfrm>
+          <a:prstGeom prst="rect">
+            <a:avLst/>
+          </a:prstGeom>
+        </p:spPr>
+      </p:pic>
     </p:spTree>
   </p:cSld>
   <mc:AlternateContent>
@@ -12991,6 +13659,10 @@
           </a:effectRef>
           <a:fontRef idx="minor"/>
         </p:style>
+        <p:txBody>
+          <a:bodyPr/>
+          <a:p/>
+        </p:txBody>
       </p:sp>
       <p:sp>
         <p:nvSpPr>
@@ -13022,7 +13694,7 @@
             <a:spAutoFit/>
           </a:bodyPr>
           <a:p>
-            <a:pPr>
+            <a:pPr algn="ctr">
               <a:lnSpc>
                 <a:spcPct val="100000"/>
               </a:lnSpc>
@@ -13387,6 +14059,30 @@
           </a:p>
         </p:txBody>
       </p:sp>
+      <p:pic>
+        <p:nvPicPr>
+          <p:cNvPr id="61" name="CU_LOGO" descr="cu logo.png"/>
+          <p:cNvPicPr>
+            <a:picLocks noChangeAspect="1"/>
+          </p:cNvPicPr>
+          <p:nvPr/>
+        </p:nvPicPr>
+        <p:blipFill>
+          <a:blip r:embed="rId2"/>
+          <a:stretch>
+            <a:fillRect/>
+          </a:stretch>
+        </p:blipFill>
+        <p:spPr>
+          <a:xfrm>
+            <a:off x="10610088" y="109728"/>
+            <a:ext cx="1417320" cy="384048"/>
+          </a:xfrm>
+          <a:prstGeom prst="rect">
+            <a:avLst/>
+          </a:prstGeom>
+        </p:spPr>
+      </p:pic>
     </p:spTree>
   </p:cSld>
   <mc:AlternateContent>
@@ -13457,6 +14153,10 @@
           </a:effectRef>
           <a:fontRef idx="minor"/>
         </p:style>
+        <p:txBody>
+          <a:bodyPr/>
+          <a:p/>
+        </p:txBody>
       </p:sp>
       <p:sp>
         <p:nvSpPr>
@@ -13488,7 +14188,7 @@
             <a:spAutoFit/>
           </a:bodyPr>
           <a:p>
-            <a:pPr>
+            <a:pPr algn="ctr">
               <a:lnSpc>
                 <a:spcPct val="100000"/>
               </a:lnSpc>
@@ -13834,6 +14534,30 @@
           </a:p>
         </p:txBody>
       </p:sp>
+      <p:pic>
+        <p:nvPicPr>
+          <p:cNvPr id="66" name="CU_LOGO" descr="cu logo.png"/>
+          <p:cNvPicPr>
+            <a:picLocks noChangeAspect="1"/>
+          </p:cNvPicPr>
+          <p:nvPr/>
+        </p:nvPicPr>
+        <p:blipFill>
+          <a:blip r:embed="rId2"/>
+          <a:stretch>
+            <a:fillRect/>
+          </a:stretch>
+        </p:blipFill>
+        <p:spPr>
+          <a:xfrm>
+            <a:off x="10610088" y="109728"/>
+            <a:ext cx="1417320" cy="384048"/>
+          </a:xfrm>
+          <a:prstGeom prst="rect">
+            <a:avLst/>
+          </a:prstGeom>
+        </p:spPr>
+      </p:pic>
     </p:spTree>
   </p:cSld>
   <mc:AlternateContent>
@@ -13904,6 +14628,10 @@
           </a:effectRef>
           <a:fontRef idx="minor"/>
         </p:style>
+        <p:txBody>
+          <a:bodyPr/>
+          <a:p/>
+        </p:txBody>
       </p:sp>
       <p:sp>
         <p:nvSpPr>
@@ -13935,7 +14663,7 @@
             <a:spAutoFit/>
           </a:bodyPr>
           <a:p>
-            <a:pPr>
+            <a:pPr algn="ctr">
               <a:lnSpc>
                 <a:spcPct val="100000"/>
               </a:lnSpc>
@@ -13996,6 +14724,10 @@
           </a:effectRef>
           <a:fontRef idx="minor"/>
         </p:style>
+        <p:txBody>
+          <a:bodyPr/>
+          <a:p/>
+        </p:txBody>
       </p:sp>
       <p:sp>
         <p:nvSpPr>
@@ -14037,6 +14769,10 @@
           </a:effectRef>
           <a:fontRef idx="minor"/>
         </p:style>
+        <p:txBody>
+          <a:bodyPr/>
+          <a:p/>
+        </p:txBody>
       </p:sp>
       <p:sp>
         <p:nvSpPr>
@@ -14816,6 +15552,30 @@
           </a:p>
         </p:txBody>
       </p:sp>
+      <p:pic>
+        <p:nvPicPr>
+          <p:cNvPr id="76" name="CU_LOGO" descr="cu logo.png"/>
+          <p:cNvPicPr>
+            <a:picLocks noChangeAspect="1"/>
+          </p:cNvPicPr>
+          <p:nvPr/>
+        </p:nvPicPr>
+        <p:blipFill>
+          <a:blip r:embed="rId2"/>
+          <a:stretch>
+            <a:fillRect/>
+          </a:stretch>
+        </p:blipFill>
+        <p:spPr>
+          <a:xfrm>
+            <a:off x="10610088" y="109728"/>
+            <a:ext cx="1417320" cy="384048"/>
+          </a:xfrm>
+          <a:prstGeom prst="rect">
+            <a:avLst/>
+          </a:prstGeom>
+        </p:spPr>
+      </p:pic>
     </p:spTree>
   </p:cSld>
   <mc:AlternateContent>
@@ -14886,6 +15646,10 @@
           </a:effectRef>
           <a:fontRef idx="minor"/>
         </p:style>
+        <p:txBody>
+          <a:bodyPr/>
+          <a:p/>
+        </p:txBody>
       </p:sp>
       <p:sp>
         <p:nvSpPr>
@@ -14917,7 +15681,7 @@
             <a:spAutoFit/>
           </a:bodyPr>
           <a:p>
-            <a:pPr>
+            <a:pPr algn="ctr">
               <a:lnSpc>
                 <a:spcPct val="100000"/>
               </a:lnSpc>
@@ -14978,6 +15742,10 @@
           </a:effectRef>
           <a:fontRef idx="minor"/>
         </p:style>
+        <p:txBody>
+          <a:bodyPr/>
+          <a:p/>
+        </p:txBody>
       </p:sp>
       <p:sp>
         <p:nvSpPr>
@@ -15135,6 +15903,10 @@
           </a:effectRef>
           <a:fontRef idx="minor"/>
         </p:style>
+        <p:txBody>
+          <a:bodyPr/>
+          <a:p/>
+        </p:txBody>
       </p:sp>
       <p:sp>
         <p:nvSpPr>
@@ -15292,6 +16064,10 @@
           </a:effectRef>
           <a:fontRef idx="minor"/>
         </p:style>
+        <p:txBody>
+          <a:bodyPr/>
+          <a:p/>
+        </p:txBody>
       </p:sp>
       <p:sp>
         <p:nvSpPr>
@@ -15664,6 +16440,30 @@
           </a:p>
         </p:txBody>
       </p:sp>
+      <p:pic>
+        <p:nvPicPr>
+          <p:cNvPr id="92" name="CU_LOGO" descr="cu logo.png"/>
+          <p:cNvPicPr>
+            <a:picLocks noChangeAspect="1"/>
+          </p:cNvPicPr>
+          <p:nvPr/>
+        </p:nvPicPr>
+        <p:blipFill>
+          <a:blip r:embed="rId2"/>
+          <a:stretch>
+            <a:fillRect/>
+          </a:stretch>
+        </p:blipFill>
+        <p:spPr>
+          <a:xfrm>
+            <a:off x="10610088" y="109728"/>
+            <a:ext cx="1417320" cy="384048"/>
+          </a:xfrm>
+          <a:prstGeom prst="rect">
+            <a:avLst/>
+          </a:prstGeom>
+        </p:spPr>
+      </p:pic>
     </p:spTree>
   </p:cSld>
   <mc:AlternateContent>
@@ -15734,6 +16534,10 @@
           </a:effectRef>
           <a:fontRef idx="minor"/>
         </p:style>
+        <p:txBody>
+          <a:bodyPr/>
+          <a:p/>
+        </p:txBody>
       </p:sp>
       <p:sp>
         <p:nvSpPr>
@@ -15765,7 +16569,7 @@
             <a:spAutoFit/>
           </a:bodyPr>
           <a:p>
-            <a:pPr>
+            <a:pPr algn="ctr">
               <a:lnSpc>
                 <a:spcPct val="100000"/>
               </a:lnSpc>
@@ -15962,6 +16766,30 @@
           </a:p>
         </p:txBody>
       </p:sp>
+      <p:pic>
+        <p:nvPicPr>
+          <p:cNvPr id="98" name="CU_LOGO" descr="cu logo.png"/>
+          <p:cNvPicPr>
+            <a:picLocks noChangeAspect="1"/>
+          </p:cNvPicPr>
+          <p:nvPr/>
+        </p:nvPicPr>
+        <p:blipFill>
+          <a:blip r:embed="rId3"/>
+          <a:stretch>
+            <a:fillRect/>
+          </a:stretch>
+        </p:blipFill>
+        <p:spPr>
+          <a:xfrm>
+            <a:off x="10610088" y="109728"/>
+            <a:ext cx="1417320" cy="384048"/>
+          </a:xfrm>
+          <a:prstGeom prst="rect">
+            <a:avLst/>
+          </a:prstGeom>
+        </p:spPr>
+      </p:pic>
     </p:spTree>
   </p:cSld>
   <mc:AlternateContent>
@@ -16032,6 +16860,10 @@
           </a:effectRef>
           <a:fontRef idx="minor"/>
         </p:style>
+        <p:txBody>
+          <a:bodyPr/>
+          <a:p/>
+        </p:txBody>
       </p:sp>
       <p:sp>
         <p:nvSpPr>
@@ -16063,7 +16895,7 @@
             <a:spAutoFit/>
           </a:bodyPr>
           <a:p>
-            <a:pPr>
+            <a:pPr algn="ctr">
               <a:lnSpc>
                 <a:spcPct val="100000"/>
               </a:lnSpc>
@@ -16260,6 +17092,30 @@
           </a:p>
         </p:txBody>
       </p:sp>
+      <p:pic>
+        <p:nvPicPr>
+          <p:cNvPr id="104" name="CU_LOGO" descr="cu logo.png"/>
+          <p:cNvPicPr>
+            <a:picLocks noChangeAspect="1"/>
+          </p:cNvPicPr>
+          <p:nvPr/>
+        </p:nvPicPr>
+        <p:blipFill>
+          <a:blip r:embed="rId3"/>
+          <a:stretch>
+            <a:fillRect/>
+          </a:stretch>
+        </p:blipFill>
+        <p:spPr>
+          <a:xfrm>
+            <a:off x="10610088" y="109728"/>
+            <a:ext cx="1417320" cy="384048"/>
+          </a:xfrm>
+          <a:prstGeom prst="rect">
+            <a:avLst/>
+          </a:prstGeom>
+        </p:spPr>
+      </p:pic>
     </p:spTree>
   </p:cSld>
   <mc:AlternateContent>
@@ -16330,6 +17186,10 @@
           </a:effectRef>
           <a:fontRef idx="minor"/>
         </p:style>
+        <p:txBody>
+          <a:bodyPr/>
+          <a:p/>
+        </p:txBody>
       </p:sp>
       <p:sp>
         <p:nvSpPr>
@@ -16361,7 +17221,7 @@
             <a:spAutoFit/>
           </a:bodyPr>
           <a:p>
-            <a:pPr>
+            <a:pPr algn="ctr">
               <a:lnSpc>
                 <a:spcPct val="100000"/>
               </a:lnSpc>
@@ -16558,6 +17418,30 @@
           </a:p>
         </p:txBody>
       </p:sp>
+      <p:pic>
+        <p:nvPicPr>
+          <p:cNvPr id="110" name="CU_LOGO" descr="cu logo.png"/>
+          <p:cNvPicPr>
+            <a:picLocks noChangeAspect="1"/>
+          </p:cNvPicPr>
+          <p:nvPr/>
+        </p:nvPicPr>
+        <p:blipFill>
+          <a:blip r:embed="rId3"/>
+          <a:stretch>
+            <a:fillRect/>
+          </a:stretch>
+        </p:blipFill>
+        <p:spPr>
+          <a:xfrm>
+            <a:off x="10610088" y="109728"/>
+            <a:ext cx="1417320" cy="384048"/>
+          </a:xfrm>
+          <a:prstGeom prst="rect">
+            <a:avLst/>
+          </a:prstGeom>
+        </p:spPr>
+      </p:pic>
     </p:spTree>
   </p:cSld>
   <mc:AlternateContent>

</xml_diff>